<commit_message>
bloc 4 data + bloc 3 final docker update
</commit_message>
<xml_diff>
--- a/AIA_Architecte_Intelligence_Artificielle/Bloc_3_Pipeline_IA/project_summary_details/overall_architecture/Architecture_Fraud_Detection.pptx
+++ b/AIA_Architecte_Intelligence_Artificielle/Bloc_3_Pipeline_IA/project_summary_details/overall_architecture/Architecture_Fraud_Detection.pptx
@@ -197,7 +197,7 @@
           <a:p>
             <a:fld id="{9C62B7FE-2222-434C-9341-6E093E2CFAA4}" type="datetimeFigureOut">
               <a:rPr lang="fr-FR" smtClean="0"/>
-              <a:t>27/09/2025</a:t>
+              <a:t>16/11/2025</a:t>
             </a:fld>
             <a:endParaRPr lang="fr-FR"/>
           </a:p>
@@ -611,7 +611,7 @@
           <a:p>
             <a:fld id="{1B006B2C-3CAE-4EA5-9F5D-D2B76FE68327}" type="datetimeFigureOut">
               <a:rPr lang="fr-FR" smtClean="0"/>
-              <a:t>27/09/2025</a:t>
+              <a:t>16/11/2025</a:t>
             </a:fld>
             <a:endParaRPr lang="fr-FR"/>
           </a:p>
@@ -809,7 +809,7 @@
           <a:p>
             <a:fld id="{1B006B2C-3CAE-4EA5-9F5D-D2B76FE68327}" type="datetimeFigureOut">
               <a:rPr lang="fr-FR" smtClean="0"/>
-              <a:t>27/09/2025</a:t>
+              <a:t>16/11/2025</a:t>
             </a:fld>
             <a:endParaRPr lang="fr-FR"/>
           </a:p>
@@ -1017,7 +1017,7 @@
           <a:p>
             <a:fld id="{1B006B2C-3CAE-4EA5-9F5D-D2B76FE68327}" type="datetimeFigureOut">
               <a:rPr lang="fr-FR" smtClean="0"/>
-              <a:t>27/09/2025</a:t>
+              <a:t>16/11/2025</a:t>
             </a:fld>
             <a:endParaRPr lang="fr-FR"/>
           </a:p>
@@ -1215,7 +1215,7 @@
           <a:p>
             <a:fld id="{1B006B2C-3CAE-4EA5-9F5D-D2B76FE68327}" type="datetimeFigureOut">
               <a:rPr lang="fr-FR" smtClean="0"/>
-              <a:t>27/09/2025</a:t>
+              <a:t>16/11/2025</a:t>
             </a:fld>
             <a:endParaRPr lang="fr-FR"/>
           </a:p>
@@ -1490,7 +1490,7 @@
           <a:p>
             <a:fld id="{1B006B2C-3CAE-4EA5-9F5D-D2B76FE68327}" type="datetimeFigureOut">
               <a:rPr lang="fr-FR" smtClean="0"/>
-              <a:t>27/09/2025</a:t>
+              <a:t>16/11/2025</a:t>
             </a:fld>
             <a:endParaRPr lang="fr-FR"/>
           </a:p>
@@ -1755,7 +1755,7 @@
           <a:p>
             <a:fld id="{1B006B2C-3CAE-4EA5-9F5D-D2B76FE68327}" type="datetimeFigureOut">
               <a:rPr lang="fr-FR" smtClean="0"/>
-              <a:t>27/09/2025</a:t>
+              <a:t>16/11/2025</a:t>
             </a:fld>
             <a:endParaRPr lang="fr-FR"/>
           </a:p>
@@ -2167,7 +2167,7 @@
           <a:p>
             <a:fld id="{1B006B2C-3CAE-4EA5-9F5D-D2B76FE68327}" type="datetimeFigureOut">
               <a:rPr lang="fr-FR" smtClean="0"/>
-              <a:t>27/09/2025</a:t>
+              <a:t>16/11/2025</a:t>
             </a:fld>
             <a:endParaRPr lang="fr-FR"/>
           </a:p>
@@ -2308,7 +2308,7 @@
           <a:p>
             <a:fld id="{1B006B2C-3CAE-4EA5-9F5D-D2B76FE68327}" type="datetimeFigureOut">
               <a:rPr lang="fr-FR" smtClean="0"/>
-              <a:t>27/09/2025</a:t>
+              <a:t>16/11/2025</a:t>
             </a:fld>
             <a:endParaRPr lang="fr-FR"/>
           </a:p>
@@ -2421,7 +2421,7 @@
           <a:p>
             <a:fld id="{1B006B2C-3CAE-4EA5-9F5D-D2B76FE68327}" type="datetimeFigureOut">
               <a:rPr lang="fr-FR" smtClean="0"/>
-              <a:t>27/09/2025</a:t>
+              <a:t>16/11/2025</a:t>
             </a:fld>
             <a:endParaRPr lang="fr-FR"/>
           </a:p>
@@ -2732,7 +2732,7 @@
           <a:p>
             <a:fld id="{1B006B2C-3CAE-4EA5-9F5D-D2B76FE68327}" type="datetimeFigureOut">
               <a:rPr lang="fr-FR" smtClean="0"/>
-              <a:t>27/09/2025</a:t>
+              <a:t>16/11/2025</a:t>
             </a:fld>
             <a:endParaRPr lang="fr-FR"/>
           </a:p>
@@ -3020,7 +3020,7 @@
           <a:p>
             <a:fld id="{1B006B2C-3CAE-4EA5-9F5D-D2B76FE68327}" type="datetimeFigureOut">
               <a:rPr lang="fr-FR" smtClean="0"/>
-              <a:t>27/09/2025</a:t>
+              <a:t>16/11/2025</a:t>
             </a:fld>
             <a:endParaRPr lang="fr-FR"/>
           </a:p>
@@ -3261,7 +3261,7 @@
           <a:p>
             <a:fld id="{1B006B2C-3CAE-4EA5-9F5D-D2B76FE68327}" type="datetimeFigureOut">
               <a:rPr lang="fr-FR" smtClean="0"/>
-              <a:t>27/09/2025</a:t>
+              <a:t>16/11/2025</a:t>
             </a:fld>
             <a:endParaRPr lang="fr-FR"/>
           </a:p>

</xml_diff>